<commit_message>
Add zone-matching analysis, prediction contract, and audit charts
- Section 0: prediction contract (what success looks like, 5.6 framework)
- Section 3: zone-matching analysis using Keena's weekend spike method
- Full 9M-row occupancy dataset processed; all zones show delta<7ppm vs expected 50-200ppm
- All Pearson r negative - sensor 0326 not co-located with any monitored zone
- Charts 7-10 added: data audit, train/test timeline, success assessment, zone matching
- PPTX expanded to 12 slides (prediction contract + zone matching slides added)
- Report and docx regenerated with full updated content

Co-Authored-By: Claude Sonnet 4.6 <noreply@anthropic.com>
Claude-Session: https://claude.ai/code/session_01Qyg8J1LbQeWtx45vRvZA1r
</commit_message>
<xml_diff>
--- a/docs/MMA3001_Presentation.pptx
+++ b/docs/MMA3001_Presentation.pptx
@@ -7,7 +7,9 @@
   <p:sldIdLst>
     <p:sldId id="256" r:id="rId7"/>
     <p:sldId id="257" r:id="rId8"/>
+    <p:sldId id="266" r:id="rId17"/>
     <p:sldId id="258" r:id="rId9"/>
+    <p:sldId id="267" r:id="rId18"/>
     <p:sldId id="259" r:id="rId10"/>
     <p:sldId id="260" r:id="rId11"/>
     <p:sldId id="261" r:id="rId12"/>
@@ -4100,6 +4102,1020 @@
                 </a:solidFill>
               </a:rPr>
               <a:t>Tanmay Gupta  ·  MMA3001  ·  Monash University  ·  2026</a:t>
+            </a:r>
+          </a:p>
+        </p:txBody>
+      </p:sp>
+    </p:spTree>
+  </p:cSld>
+  <p:clrMapOvr>
+    <a:masterClrMapping/>
+  </p:clrMapOvr>
+</p:sld>
+</file>
+
+<file path=ppt/slides/slide11.xml><?xml version="1.0" encoding="utf-8"?>
+<p:sld xmlns:a="http://schemas.openxmlformats.org/drawingml/2006/main" xmlns:p="http://schemas.openxmlformats.org/presentationml/2006/main" xmlns:r="http://schemas.openxmlformats.org/officeDocument/2006/relationships">
+  <p:cSld>
+    <p:spTree>
+      <p:nvGrpSpPr>
+        <p:cNvPr id="1" name=""/>
+        <p:cNvGrpSpPr/>
+        <p:nvPr/>
+      </p:nvGrpSpPr>
+      <p:grpSpPr/>
+      <p:sp>
+        <p:nvSpPr>
+          <p:cNvPr id="2" name="Rectangle 1"/>
+          <p:cNvSpPr/>
+          <p:nvPr/>
+        </p:nvSpPr>
+        <p:spPr>
+          <a:xfrm>
+            <a:off x="0" y="0"/>
+            <a:ext cx="9144000" cy="1005840"/>
+          </a:xfrm>
+          <a:prstGeom prst="rect">
+            <a:avLst/>
+          </a:prstGeom>
+          <a:solidFill>
+            <a:srgbClr val="2A78D6"/>
+          </a:solidFill>
+          <a:ln>
+            <a:noFill/>
+          </a:ln>
+        </p:spPr>
+        <p:style>
+          <a:lnRef idx="1">
+            <a:schemeClr val="accent1"/>
+          </a:lnRef>
+          <a:fillRef idx="3">
+            <a:schemeClr val="accent1"/>
+          </a:fillRef>
+          <a:effectRef idx="2">
+            <a:schemeClr val="accent1"/>
+          </a:effectRef>
+          <a:fontRef idx="minor">
+            <a:schemeClr val="lt1"/>
+          </a:fontRef>
+        </p:style>
+        <p:txBody>
+          <a:bodyPr rtlCol="0" anchor="ctr"/>
+          <a:lstStyle/>
+          <a:p>
+            <a:pPr algn="ctr"/>
+          </a:p>
+        </p:txBody>
+      </p:sp>
+      <p:sp>
+        <p:nvSpPr>
+          <p:cNvPr id="3" name="TextBox 2"/>
+          <p:cNvSpPr txBox="1"/>
+          <p:nvPr/>
+        </p:nvSpPr>
+        <p:spPr>
+          <a:xfrm>
+            <a:off x="182880" y="91440"/>
+            <a:ext cx="8686800" cy="822960"/>
+          </a:xfrm>
+          <a:prstGeom prst="rect">
+            <a:avLst/>
+          </a:prstGeom>
+          <a:noFill/>
+        </p:spPr>
+        <p:txBody>
+          <a:bodyPr wrap="square">
+            <a:spAutoFit/>
+          </a:bodyPr>
+          <a:lstStyle/>
+          <a:p>
+            <a:pPr algn="l"/>
+            <a:r>
+              <a:rPr sz="2400" b="1">
+                <a:solidFill>
+                  <a:srgbClr val="FFFFFF"/>
+                </a:solidFill>
+              </a:rPr>
+              <a:t>Prediction Contract — What Success Looks Like</a:t>
+            </a:r>
+          </a:p>
+        </p:txBody>
+      </p:sp>
+      <p:sp>
+        <p:nvSpPr>
+          <p:cNvPr id="4" name="TextBox 3"/>
+          <p:cNvSpPr txBox="1"/>
+          <p:nvPr/>
+        </p:nvSpPr>
+        <p:spPr>
+          <a:xfrm>
+            <a:off x="182880" y="685800"/>
+            <a:ext cx="8686800" cy="320040"/>
+          </a:xfrm>
+          <a:prstGeom prst="rect">
+            <a:avLst/>
+          </a:prstGeom>
+          <a:noFill/>
+        </p:spPr>
+        <p:txBody>
+          <a:bodyPr wrap="square">
+            <a:spAutoFit/>
+          </a:bodyPr>
+          <a:lstStyle/>
+          <a:p>
+            <a:pPr algn="l"/>
+            <a:r>
+              <a:rPr sz="1200" b="0">
+                <a:solidFill>
+                  <a:srgbClr val="C0D8F5"/>
+                </a:solidFill>
+              </a:rPr>
+              <a:t>Defined before running any model  ·  Week 5.6 framework</a:t>
+            </a:r>
+          </a:p>
+        </p:txBody>
+      </p:sp>
+      <p:sp>
+        <p:nvSpPr>
+          <p:cNvPr id="5" name="Rectangle 4"/>
+          <p:cNvSpPr/>
+          <p:nvPr/>
+        </p:nvSpPr>
+        <p:spPr>
+          <a:xfrm>
+            <a:off x="274320" y="1143000"/>
+            <a:ext cx="2651760" cy="411480"/>
+          </a:xfrm>
+          <a:prstGeom prst="rect">
+            <a:avLst/>
+          </a:prstGeom>
+          <a:solidFill>
+            <a:srgbClr val="2A78D6"/>
+          </a:solidFill>
+          <a:ln>
+            <a:noFill/>
+          </a:ln>
+        </p:spPr>
+        <p:style>
+          <a:lnRef idx="1">
+            <a:schemeClr val="accent1"/>
+          </a:lnRef>
+          <a:fillRef idx="3">
+            <a:schemeClr val="accent1"/>
+          </a:fillRef>
+          <a:effectRef idx="2">
+            <a:schemeClr val="accent1"/>
+          </a:effectRef>
+          <a:fontRef idx="minor">
+            <a:schemeClr val="lt1"/>
+          </a:fontRef>
+        </p:style>
+        <p:txBody>
+          <a:bodyPr rtlCol="0" anchor="ctr"/>
+          <a:lstStyle/>
+          <a:p>
+            <a:pPr algn="ctr"/>
+          </a:p>
+        </p:txBody>
+      </p:sp>
+      <p:sp>
+        <p:nvSpPr>
+          <p:cNvPr id="6" name="TextBox 5"/>
+          <p:cNvSpPr txBox="1"/>
+          <p:nvPr/>
+        </p:nvSpPr>
+        <p:spPr>
+          <a:xfrm>
+            <a:off x="365760" y="1170432"/>
+            <a:ext cx="2468880" cy="365760"/>
+          </a:xfrm>
+          <a:prstGeom prst="rect">
+            <a:avLst/>
+          </a:prstGeom>
+          <a:noFill/>
+        </p:spPr>
+        <p:txBody>
+          <a:bodyPr wrap="square">
+            <a:spAutoFit/>
+          </a:bodyPr>
+          <a:lstStyle/>
+          <a:p>
+            <a:pPr algn="l"/>
+            <a:r>
+              <a:rPr sz="1400" b="1">
+                <a:solidFill>
+                  <a:srgbClr val="FFFFFF"/>
+                </a:solidFill>
+              </a:rPr>
+              <a:t>MAE ≤ 10 ppm</a:t>
+            </a:r>
+          </a:p>
+        </p:txBody>
+      </p:sp>
+      <p:sp>
+        <p:nvSpPr>
+          <p:cNvPr id="7" name="TextBox 6"/>
+          <p:cNvSpPr txBox="1"/>
+          <p:nvPr/>
+        </p:nvSpPr>
+        <p:spPr>
+          <a:xfrm>
+            <a:off x="320040" y="1600200"/>
+            <a:ext cx="2606040" cy="822960"/>
+          </a:xfrm>
+          <a:prstGeom prst="rect">
+            <a:avLst/>
+          </a:prstGeom>
+          <a:noFill/>
+        </p:spPr>
+        <p:txBody>
+          <a:bodyPr wrap="square">
+            <a:spAutoFit/>
+          </a:bodyPr>
+          <a:lstStyle/>
+          <a:p>
+            <a:pPr algn="l"/>
+            <a:r>
+              <a:rPr sz="1050" b="0">
+                <a:solidFill>
+                  <a:srgbClr val="52514E"/>
+                </a:solidFill>
+              </a:rPr>
+              <a:t>Below typical reading-to-reading variation.
+Useful as a ventilation trend signal.</a:t>
+            </a:r>
+          </a:p>
+        </p:txBody>
+      </p:sp>
+      <p:sp>
+        <p:nvSpPr>
+          <p:cNvPr id="8" name="Rectangle 7"/>
+          <p:cNvSpPr/>
+          <p:nvPr/>
+        </p:nvSpPr>
+        <p:spPr>
+          <a:xfrm>
+            <a:off x="3200400" y="1143000"/>
+            <a:ext cx="2651760" cy="411480"/>
+          </a:xfrm>
+          <a:prstGeom prst="rect">
+            <a:avLst/>
+          </a:prstGeom>
+          <a:solidFill>
+            <a:srgbClr val="1BAF7A"/>
+          </a:solidFill>
+          <a:ln>
+            <a:noFill/>
+          </a:ln>
+        </p:spPr>
+        <p:style>
+          <a:lnRef idx="1">
+            <a:schemeClr val="accent1"/>
+          </a:lnRef>
+          <a:fillRef idx="3">
+            <a:schemeClr val="accent1"/>
+          </a:fillRef>
+          <a:effectRef idx="2">
+            <a:schemeClr val="accent1"/>
+          </a:effectRef>
+          <a:fontRef idx="minor">
+            <a:schemeClr val="lt1"/>
+          </a:fontRef>
+        </p:style>
+        <p:txBody>
+          <a:bodyPr rtlCol="0" anchor="ctr"/>
+          <a:lstStyle/>
+          <a:p>
+            <a:pPr algn="ctr"/>
+          </a:p>
+        </p:txBody>
+      </p:sp>
+      <p:sp>
+        <p:nvSpPr>
+          <p:cNvPr id="9" name="TextBox 8"/>
+          <p:cNvSpPr txBox="1"/>
+          <p:nvPr/>
+        </p:nvSpPr>
+        <p:spPr>
+          <a:xfrm>
+            <a:off x="3291840" y="1170432"/>
+            <a:ext cx="2468880" cy="365760"/>
+          </a:xfrm>
+          <a:prstGeom prst="rect">
+            <a:avLst/>
+          </a:prstGeom>
+          <a:noFill/>
+        </p:spPr>
+        <p:txBody>
+          <a:bodyPr wrap="square">
+            <a:spAutoFit/>
+          </a:bodyPr>
+          <a:lstStyle/>
+          <a:p>
+            <a:pPr algn="l"/>
+            <a:r>
+              <a:rPr sz="1400" b="1">
+                <a:solidFill>
+                  <a:srgbClr val="FFFFFF"/>
+                </a:solidFill>
+              </a:rPr>
+              <a:t>R² ≥ 0.25</a:t>
+            </a:r>
+          </a:p>
+        </p:txBody>
+      </p:sp>
+      <p:sp>
+        <p:nvSpPr>
+          <p:cNvPr id="10" name="TextBox 9"/>
+          <p:cNvSpPr txBox="1"/>
+          <p:nvPr/>
+        </p:nvSpPr>
+        <p:spPr>
+          <a:xfrm>
+            <a:off x="3246120" y="1600200"/>
+            <a:ext cx="2606040" cy="822960"/>
+          </a:xfrm>
+          <a:prstGeom prst="rect">
+            <a:avLst/>
+          </a:prstGeom>
+          <a:noFill/>
+        </p:spPr>
+        <p:txBody>
+          <a:bodyPr wrap="square">
+            <a:spAutoFit/>
+          </a:bodyPr>
+          <a:lstStyle/>
+          <a:p>
+            <a:pPr algn="l"/>
+            <a:r>
+              <a:rPr sz="1050" b="0">
+                <a:solidFill>
+                  <a:srgbClr val="52514E"/>
+                </a:solidFill>
+              </a:rPr>
+              <a:t>Explains at least a quarter of variance.
+Captures real structure, not just the mean.</a:t>
+            </a:r>
+          </a:p>
+        </p:txBody>
+      </p:sp>
+      <p:sp>
+        <p:nvSpPr>
+          <p:cNvPr id="11" name="Rectangle 10"/>
+          <p:cNvSpPr/>
+          <p:nvPr/>
+        </p:nvSpPr>
+        <p:spPr>
+          <a:xfrm>
+            <a:off x="6126480" y="1143000"/>
+            <a:ext cx="2651760" cy="411480"/>
+          </a:xfrm>
+          <a:prstGeom prst="rect">
+            <a:avLst/>
+          </a:prstGeom>
+          <a:solidFill>
+            <a:srgbClr val="EB6834"/>
+          </a:solidFill>
+          <a:ln>
+            <a:noFill/>
+          </a:ln>
+        </p:spPr>
+        <p:style>
+          <a:lnRef idx="1">
+            <a:schemeClr val="accent1"/>
+          </a:lnRef>
+          <a:fillRef idx="3">
+            <a:schemeClr val="accent1"/>
+          </a:fillRef>
+          <a:effectRef idx="2">
+            <a:schemeClr val="accent1"/>
+          </a:effectRef>
+          <a:fontRef idx="minor">
+            <a:schemeClr val="lt1"/>
+          </a:fontRef>
+        </p:style>
+        <p:txBody>
+          <a:bodyPr rtlCol="0" anchor="ctr"/>
+          <a:lstStyle/>
+          <a:p>
+            <a:pPr algn="ctr"/>
+          </a:p>
+        </p:txBody>
+      </p:sp>
+      <p:sp>
+        <p:nvSpPr>
+          <p:cNvPr id="12" name="TextBox 11"/>
+          <p:cNvSpPr txBox="1"/>
+          <p:nvPr/>
+        </p:nvSpPr>
+        <p:spPr>
+          <a:xfrm>
+            <a:off x="6217920" y="1170432"/>
+            <a:ext cx="2468880" cy="365760"/>
+          </a:xfrm>
+          <a:prstGeom prst="rect">
+            <a:avLst/>
+          </a:prstGeom>
+          <a:noFill/>
+        </p:spPr>
+        <p:txBody>
+          <a:bodyPr wrap="square">
+            <a:spAutoFit/>
+          </a:bodyPr>
+          <a:lstStyle/>
+          <a:p>
+            <a:pPr algn="l"/>
+            <a:r>
+              <a:rPr sz="1400" b="1">
+                <a:solidFill>
+                  <a:srgbClr val="FFFFFF"/>
+                </a:solidFill>
+              </a:rPr>
+              <a:t>No data leakage</a:t>
+            </a:r>
+          </a:p>
+        </p:txBody>
+      </p:sp>
+      <p:sp>
+        <p:nvSpPr>
+          <p:cNvPr id="13" name="TextBox 12"/>
+          <p:cNvSpPr txBox="1"/>
+          <p:nvPr/>
+        </p:nvSpPr>
+        <p:spPr>
+          <a:xfrm>
+            <a:off x="6172200" y="1600200"/>
+            <a:ext cx="2606040" cy="822960"/>
+          </a:xfrm>
+          <a:prstGeom prst="rect">
+            <a:avLst/>
+          </a:prstGeom>
+          <a:noFill/>
+        </p:spPr>
+        <p:txBody>
+          <a:bodyPr wrap="square">
+            <a:spAutoFit/>
+          </a:bodyPr>
+          <a:lstStyle/>
+          <a:p>
+            <a:pPr algn="l"/>
+            <a:r>
+              <a:rPr sz="1050" b="0">
+                <a:solidFill>
+                  <a:srgbClr val="52514E"/>
+                </a:solidFill>
+              </a:rPr>
+              <a:t>Test set must be strictly in the future.
+Time-ordered split required — not random.</a:t>
+            </a:r>
+          </a:p>
+        </p:txBody>
+      </p:sp>
+      <p:sp>
+        <p:nvSpPr>
+          <p:cNvPr id="14" name="TextBox 13"/>
+          <p:cNvSpPr txBox="1"/>
+          <p:nvPr/>
+        </p:nvSpPr>
+        <p:spPr>
+          <a:xfrm>
+            <a:off x="274320" y="2514600"/>
+            <a:ext cx="8503920" cy="640080"/>
+          </a:xfrm>
+          <a:prstGeom prst="rect">
+            <a:avLst/>
+          </a:prstGeom>
+          <a:noFill/>
+        </p:spPr>
+        <p:txBody>
+          <a:bodyPr wrap="square">
+            <a:spAutoFit/>
+          </a:bodyPr>
+          <a:lstStyle/>
+          <a:p>
+            <a:pPr algn="l"/>
+            <a:r>
+              <a:rPr sz="1150" b="0">
+                <a:solidFill>
+                  <a:srgbClr val="52514E"/>
+                </a:solidFill>
+              </a:rPr>
+              <a:t>Key risk: Occupancy data only helps if the sensor is in a monitored room.
+Whether it does is answered by the zone-matching analysis — not assumed.</a:t>
+            </a:r>
+          </a:p>
+        </p:txBody>
+      </p:sp>
+      <p:sp>
+        <p:nvSpPr>
+          <p:cNvPr id="15" name="TextBox 14"/>
+          <p:cNvSpPr txBox="1"/>
+          <p:nvPr/>
+        </p:nvSpPr>
+        <p:spPr>
+          <a:xfrm>
+            <a:off x="274320" y="3200400"/>
+            <a:ext cx="1097280" cy="365760"/>
+          </a:xfrm>
+          <a:prstGeom prst="rect">
+            <a:avLst/>
+          </a:prstGeom>
+          <a:noFill/>
+        </p:spPr>
+        <p:txBody>
+          <a:bodyPr wrap="square">
+            <a:spAutoFit/>
+          </a:bodyPr>
+          <a:lstStyle/>
+          <a:p>
+            <a:pPr algn="l"/>
+            <a:r>
+              <a:rPr sz="1300" b="1">
+                <a:solidFill>
+                  <a:srgbClr val="0B0B0B"/>
+                </a:solidFill>
+              </a:rPr>
+              <a:t>Outcome →</a:t>
+            </a:r>
+          </a:p>
+        </p:txBody>
+      </p:sp>
+      <p:sp>
+        <p:nvSpPr>
+          <p:cNvPr id="16" name="TextBox 15"/>
+          <p:cNvSpPr txBox="1"/>
+          <p:nvPr/>
+        </p:nvSpPr>
+        <p:spPr>
+          <a:xfrm>
+            <a:off x="1463040" y="3154680"/>
+            <a:ext cx="1828800" cy="411480"/>
+          </a:xfrm>
+          <a:prstGeom prst="rect">
+            <a:avLst/>
+          </a:prstGeom>
+          <a:noFill/>
+        </p:spPr>
+        <p:txBody>
+          <a:bodyPr wrap="square">
+            <a:spAutoFit/>
+          </a:bodyPr>
+          <a:lstStyle/>
+          <a:p>
+            <a:pPr algn="l"/>
+            <a:r>
+              <a:rPr sz="1200" b="1">
+                <a:solidFill>
+                  <a:srgbClr val="1BAF7A"/>
+                </a:solidFill>
+              </a:rPr>
+              <a:t>✓  MAE met</a:t>
+            </a:r>
+          </a:p>
+        </p:txBody>
+      </p:sp>
+      <p:sp>
+        <p:nvSpPr>
+          <p:cNvPr id="17" name="TextBox 16"/>
+          <p:cNvSpPr txBox="1"/>
+          <p:nvPr/>
+        </p:nvSpPr>
+        <p:spPr>
+          <a:xfrm>
+            <a:off x="3383280" y="3154680"/>
+            <a:ext cx="1828800" cy="411480"/>
+          </a:xfrm>
+          <a:prstGeom prst="rect">
+            <a:avLst/>
+          </a:prstGeom>
+          <a:noFill/>
+        </p:spPr>
+        <p:txBody>
+          <a:bodyPr wrap="square">
+            <a:spAutoFit/>
+          </a:bodyPr>
+          <a:lstStyle/>
+          <a:p>
+            <a:pPr algn="l"/>
+            <a:r>
+              <a:rPr sz="1200" b="1">
+                <a:solidFill>
+                  <a:srgbClr val="1BAF7A"/>
+                </a:solidFill>
+              </a:rPr>
+              <a:t>✓  R² met (3/4 models)</a:t>
+            </a:r>
+          </a:p>
+        </p:txBody>
+      </p:sp>
+      <p:sp>
+        <p:nvSpPr>
+          <p:cNvPr id="18" name="TextBox 17"/>
+          <p:cNvSpPr txBox="1"/>
+          <p:nvPr/>
+        </p:nvSpPr>
+        <p:spPr>
+          <a:xfrm>
+            <a:off x="5303520" y="3154680"/>
+            <a:ext cx="1828800" cy="411480"/>
+          </a:xfrm>
+          <a:prstGeom prst="rect">
+            <a:avLst/>
+          </a:prstGeom>
+          <a:noFill/>
+        </p:spPr>
+        <p:txBody>
+          <a:bodyPr wrap="square">
+            <a:spAutoFit/>
+          </a:bodyPr>
+          <a:lstStyle/>
+          <a:p>
+            <a:pPr algn="l"/>
+            <a:r>
+              <a:rPr sz="1200" b="1">
+                <a:solidFill>
+                  <a:srgbClr val="1BAF7A"/>
+                </a:solidFill>
+              </a:rPr>
+              <a:t>✓  No leakage</a:t>
+            </a:r>
+          </a:p>
+        </p:txBody>
+      </p:sp>
+      <p:sp>
+        <p:nvSpPr>
+          <p:cNvPr id="19" name="TextBox 18"/>
+          <p:cNvSpPr txBox="1"/>
+          <p:nvPr/>
+        </p:nvSpPr>
+        <p:spPr>
+          <a:xfrm>
+            <a:off x="7223760" y="3154680"/>
+            <a:ext cx="1828800" cy="411480"/>
+          </a:xfrm>
+          <a:prstGeom prst="rect">
+            <a:avLst/>
+          </a:prstGeom>
+          <a:noFill/>
+        </p:spPr>
+        <p:txBody>
+          <a:bodyPr wrap="square">
+            <a:spAutoFit/>
+          </a:bodyPr>
+          <a:lstStyle/>
+          <a:p>
+            <a:pPr algn="l"/>
+            <a:r>
+              <a:rPr sz="1200" b="1">
+                <a:solidFill>
+                  <a:srgbClr val="E34948"/>
+                </a:solidFill>
+              </a:rPr>
+              <a:t>✗  Decision Tree R² = 0.19</a:t>
+            </a:r>
+          </a:p>
+        </p:txBody>
+      </p:sp>
+    </p:spTree>
+  </p:cSld>
+  <p:clrMapOvr>
+    <a:masterClrMapping/>
+  </p:clrMapOvr>
+</p:sld>
+</file>
+
+<file path=ppt/slides/slide12.xml><?xml version="1.0" encoding="utf-8"?>
+<p:sld xmlns:a="http://schemas.openxmlformats.org/drawingml/2006/main" xmlns:p="http://schemas.openxmlformats.org/presentationml/2006/main" xmlns:r="http://schemas.openxmlformats.org/officeDocument/2006/relationships">
+  <p:cSld>
+    <p:spTree>
+      <p:nvGrpSpPr>
+        <p:cNvPr id="1" name=""/>
+        <p:cNvGrpSpPr/>
+        <p:nvPr/>
+      </p:nvGrpSpPr>
+      <p:grpSpPr/>
+      <p:sp>
+        <p:nvSpPr>
+          <p:cNvPr id="2" name="Rectangle 1"/>
+          <p:cNvSpPr/>
+          <p:nvPr/>
+        </p:nvSpPr>
+        <p:spPr>
+          <a:xfrm>
+            <a:off x="0" y="0"/>
+            <a:ext cx="9144000" cy="1005840"/>
+          </a:xfrm>
+          <a:prstGeom prst="rect">
+            <a:avLst/>
+          </a:prstGeom>
+          <a:solidFill>
+            <a:srgbClr val="2A78D6"/>
+          </a:solidFill>
+          <a:ln>
+            <a:noFill/>
+          </a:ln>
+        </p:spPr>
+        <p:style>
+          <a:lnRef idx="1">
+            <a:schemeClr val="accent1"/>
+          </a:lnRef>
+          <a:fillRef idx="3">
+            <a:schemeClr val="accent1"/>
+          </a:fillRef>
+          <a:effectRef idx="2">
+            <a:schemeClr val="accent1"/>
+          </a:effectRef>
+          <a:fontRef idx="minor">
+            <a:schemeClr val="lt1"/>
+          </a:fontRef>
+        </p:style>
+        <p:txBody>
+          <a:bodyPr rtlCol="0" anchor="ctr"/>
+          <a:lstStyle/>
+          <a:p>
+            <a:pPr algn="ctr"/>
+          </a:p>
+        </p:txBody>
+      </p:sp>
+      <p:sp>
+        <p:nvSpPr>
+          <p:cNvPr id="3" name="TextBox 2"/>
+          <p:cNvSpPr txBox="1"/>
+          <p:nvPr/>
+        </p:nvSpPr>
+        <p:spPr>
+          <a:xfrm>
+            <a:off x="182880" y="91440"/>
+            <a:ext cx="8686800" cy="822960"/>
+          </a:xfrm>
+          <a:prstGeom prst="rect">
+            <a:avLst/>
+          </a:prstGeom>
+          <a:noFill/>
+        </p:spPr>
+        <p:txBody>
+          <a:bodyPr wrap="square">
+            <a:spAutoFit/>
+          </a:bodyPr>
+          <a:lstStyle/>
+          <a:p>
+            <a:pPr algn="l"/>
+            <a:r>
+              <a:rPr sz="2200" b="1">
+                <a:solidFill>
+                  <a:srgbClr val="FFFFFF"/>
+                </a:solidFill>
+              </a:rPr>
+              <a:t>Zone Matching — Can We Link Sensor to a Room?</a:t>
+            </a:r>
+          </a:p>
+        </p:txBody>
+      </p:sp>
+      <p:sp>
+        <p:nvSpPr>
+          <p:cNvPr id="4" name="TextBox 3"/>
+          <p:cNvSpPr txBox="1"/>
+          <p:nvPr/>
+        </p:nvSpPr>
+        <p:spPr>
+          <a:xfrm>
+            <a:off x="182880" y="685800"/>
+            <a:ext cx="8686800" cy="320040"/>
+          </a:xfrm>
+          <a:prstGeom prst="rect">
+            <a:avLst/>
+          </a:prstGeom>
+          <a:noFill/>
+        </p:spPr>
+        <p:txBody>
+          <a:bodyPr wrap="square">
+            <a:spAutoFit/>
+          </a:bodyPr>
+          <a:lstStyle/>
+          <a:p>
+            <a:pPr algn="l"/>
+            <a:r>
+              <a:rPr sz="1150" b="0">
+                <a:solidFill>
+                  <a:srgbClr val="C0D8F5"/>
+                </a:solidFill>
+              </a:rPr>
+              <a:t>Keena's weekend spike method · 9 million occupancy rows · 29,039 CO2 readings</a:t>
+            </a:r>
+          </a:p>
+        </p:txBody>
+      </p:sp>
+      <p:pic>
+        <p:nvPicPr>
+          <p:cNvPr id="5" name="Picture 4" descr="chart10_zone_matching.png"/>
+          <p:cNvPicPr>
+            <a:picLocks noChangeAspect="1"/>
+          </p:cNvPicPr>
+          <p:nvPr/>
+        </p:nvPicPr>
+        <p:blipFill>
+          <a:blip r:embed="rId2"/>
+          <a:stretch>
+            <a:fillRect/>
+          </a:stretch>
+        </p:blipFill>
+        <p:spPr>
+          <a:xfrm>
+            <a:off x="182880" y="1051560"/>
+            <a:ext cx="7132320" cy="3017520"/>
+          </a:xfrm>
+          <a:prstGeom prst="rect">
+            <a:avLst/>
+          </a:prstGeom>
+        </p:spPr>
+      </p:pic>
+      <p:sp>
+        <p:nvSpPr>
+          <p:cNvPr id="6" name="Rectangle 5"/>
+          <p:cNvSpPr/>
+          <p:nvPr/>
+        </p:nvSpPr>
+        <p:spPr>
+          <a:xfrm>
+            <a:off x="7406640" y="1051560"/>
+            <a:ext cx="1600200" cy="1371600"/>
+          </a:xfrm>
+          <a:prstGeom prst="rect">
+            <a:avLst/>
+          </a:prstGeom>
+          <a:solidFill>
+            <a:srgbClr val="F9F9F7"/>
+          </a:solidFill>
+          <a:ln>
+            <a:noFill/>
+          </a:ln>
+        </p:spPr>
+        <p:style>
+          <a:lnRef idx="1">
+            <a:schemeClr val="accent1"/>
+          </a:lnRef>
+          <a:fillRef idx="3">
+            <a:schemeClr val="accent1"/>
+          </a:fillRef>
+          <a:effectRef idx="2">
+            <a:schemeClr val="accent1"/>
+          </a:effectRef>
+          <a:fontRef idx="minor">
+            <a:schemeClr val="lt1"/>
+          </a:fontRef>
+        </p:style>
+        <p:txBody>
+          <a:bodyPr rtlCol="0" anchor="ctr"/>
+          <a:lstStyle/>
+          <a:p>
+            <a:pPr algn="ctr"/>
+          </a:p>
+        </p:txBody>
+      </p:sp>
+      <p:sp>
+        <p:nvSpPr>
+          <p:cNvPr id="7" name="TextBox 6"/>
+          <p:cNvSpPr txBox="1"/>
+          <p:nvPr/>
+        </p:nvSpPr>
+        <p:spPr>
+          <a:xfrm>
+            <a:off x="7452360" y="1078992"/>
+            <a:ext cx="1508760" cy="274320"/>
+          </a:xfrm>
+          <a:prstGeom prst="rect">
+            <a:avLst/>
+          </a:prstGeom>
+          <a:noFill/>
+        </p:spPr>
+        <p:txBody>
+          <a:bodyPr wrap="square">
+            <a:spAutoFit/>
+          </a:bodyPr>
+          <a:lstStyle/>
+          <a:p>
+            <a:pPr algn="l"/>
+            <a:r>
+              <a:rPr sz="900" b="1">
+                <a:solidFill>
+                  <a:srgbClr val="0B0B0B"/>
+                </a:solidFill>
+              </a:rPr>
+              <a:t>Method:</a:t>
+            </a:r>
+          </a:p>
+        </p:txBody>
+      </p:sp>
+      <p:sp>
+        <p:nvSpPr>
+          <p:cNvPr id="8" name="TextBox 7"/>
+          <p:cNvSpPr txBox="1"/>
+          <p:nvPr/>
+        </p:nvSpPr>
+        <p:spPr>
+          <a:xfrm>
+            <a:off x="7452360" y="1353312"/>
+            <a:ext cx="1508760" cy="1005840"/>
+          </a:xfrm>
+          <a:prstGeom prst="rect">
+            <a:avLst/>
+          </a:prstGeom>
+          <a:noFill/>
+        </p:spPr>
+        <p:txBody>
+          <a:bodyPr wrap="square">
+            <a:spAutoFit/>
+          </a:bodyPr>
+          <a:lstStyle/>
+          <a:p>
+            <a:pPr algn="l"/>
+            <a:r>
+              <a:rPr sz="850" b="0">
+                <a:solidFill>
+                  <a:srgbClr val="52514E"/>
+                </a:solidFill>
+              </a:rPr>
+              <a:t>1. Filter to weekends
+2. Find bins with 1 zone active
+3. Check CO2 spike
+4. Expected: +50–200 ppm</a:t>
+            </a:r>
+          </a:p>
+        </p:txBody>
+      </p:sp>
+      <p:sp>
+        <p:nvSpPr>
+          <p:cNvPr id="9" name="Rectangle 8"/>
+          <p:cNvSpPr/>
+          <p:nvPr/>
+        </p:nvSpPr>
+        <p:spPr>
+          <a:xfrm>
+            <a:off x="182880" y="4160520"/>
+            <a:ext cx="8686800" cy="685800"/>
+          </a:xfrm>
+          <a:prstGeom prst="rect">
+            <a:avLst/>
+          </a:prstGeom>
+          <a:solidFill>
+            <a:srgbClr val="FEF3F2"/>
+          </a:solidFill>
+          <a:ln>
+            <a:noFill/>
+          </a:ln>
+        </p:spPr>
+        <p:style>
+          <a:lnRef idx="1">
+            <a:schemeClr val="accent1"/>
+          </a:lnRef>
+          <a:fillRef idx="3">
+            <a:schemeClr val="accent1"/>
+          </a:fillRef>
+          <a:effectRef idx="2">
+            <a:schemeClr val="accent1"/>
+          </a:effectRef>
+          <a:fontRef idx="minor">
+            <a:schemeClr val="lt1"/>
+          </a:fontRef>
+        </p:style>
+        <p:txBody>
+          <a:bodyPr rtlCol="0" anchor="ctr"/>
+          <a:lstStyle/>
+          <a:p>
+            <a:pPr algn="ctr"/>
+          </a:p>
+        </p:txBody>
+      </p:sp>
+      <p:sp>
+        <p:nvSpPr>
+          <p:cNvPr id="10" name="TextBox 9"/>
+          <p:cNvSpPr txBox="1"/>
+          <p:nvPr/>
+        </p:nvSpPr>
+        <p:spPr>
+          <a:xfrm>
+            <a:off x="274320" y="4206240"/>
+            <a:ext cx="8412480" cy="594360"/>
+          </a:xfrm>
+          <a:prstGeom prst="rect">
+            <a:avLst/>
+          </a:prstGeom>
+          <a:noFill/>
+        </p:spPr>
+        <p:txBody>
+          <a:bodyPr wrap="square">
+            <a:spAutoFit/>
+          </a:bodyPr>
+          <a:lstStyle/>
+          <a:p>
+            <a:pPr algn="l"/>
+            <a:r>
+              <a:rPr sz="1150" b="1">
+                <a:solidFill>
+                  <a:srgbClr val="E34948"/>
+                </a:solidFill>
+              </a:rPr>
+              <a:t>✗  No zone produced a meaningful CO2 spike (largest: +6.2 ppm vs expected 50–200 ppm)  ·  All correlations are negative  ·  Sensor 0326 is not in any monitored room</a:t>
             </a:r>
           </a:p>
         </p:txBody>

</xml_diff>